<commit_message>
Corrige fotos vazando dos cantos arredondados no material de cliente
O addImage do pptxgenjs só recorta imagem em retângulo ou elipse — nunca em
roundRect. Os cards de trend do material de cliente desenhavam um contorno
roundRect por cima da foto pra simular um enquadramento, mas a foto
retangular por baixo continuava vazando pelos cantos arredondados do
contorno. Adiciona clip_pictures_to_roundrect.py, que copia a geometria
roundRect do contorno pra própria imagem direto no XML do .pptx (o formato
suporta isso nativamente, só o pptxgenjs não expõe). Regenera o material de
cliente com o corte correto.
</commit_message>
<xml_diff>
--- a/entregas-agosto26/material-cliente-agosto26.pptx
+++ b/entregas-agosto26/material-cliente-agosto26.pptx
@@ -2786,8 +2786,10 @@
             <a:off x="548640" y="1188720"/>
             <a:ext cx="5364328" cy="5120640"/>
           </a:xfrm>
-          <a:prstGeom prst="rect">
-            <a:avLst/>
+          <a:prstGeom prst="roundRect">
+            <a:avLst>
+              <a:gd name="adj" fmla="val 2679"/>
+            </a:avLst>
           </a:prstGeom>
         </p:spPr>
       </p:pic>
@@ -3050,8 +3052,10 @@
             <a:off x="6278728" y="1188720"/>
             <a:ext cx="5364328" cy="5120640"/>
           </a:xfrm>
-          <a:prstGeom prst="rect">
-            <a:avLst/>
+          <a:prstGeom prst="roundRect">
+            <a:avLst>
+              <a:gd name="adj" fmla="val 2679"/>
+            </a:avLst>
           </a:prstGeom>
         </p:spPr>
       </p:pic>
@@ -3385,8 +3389,10 @@
             <a:off x="548640" y="1188720"/>
             <a:ext cx="5364328" cy="5120640"/>
           </a:xfrm>
-          <a:prstGeom prst="rect">
-            <a:avLst/>
+          <a:prstGeom prst="roundRect">
+            <a:avLst>
+              <a:gd name="adj" fmla="val 2679"/>
+            </a:avLst>
           </a:prstGeom>
         </p:spPr>
       </p:pic>
@@ -3649,8 +3655,10 @@
             <a:off x="6278728" y="1188720"/>
             <a:ext cx="5364328" cy="5120640"/>
           </a:xfrm>
-          <a:prstGeom prst="rect">
-            <a:avLst/>
+          <a:prstGeom prst="roundRect">
+            <a:avLst>
+              <a:gd name="adj" fmla="val 2679"/>
+            </a:avLst>
           </a:prstGeom>
         </p:spPr>
       </p:pic>

</xml_diff>